<commit_message>
Correct signed integers representation
</commit_message>
<xml_diff>
--- a/figures/resources/data_types.pptx
+++ b/figures/resources/data_types.pptx
@@ -5,13 +5,14 @@
     <p:sldMasterId id="2147483648" r:id="rId1"/>
   </p:sldMasterIdLst>
   <p:notesMasterIdLst>
-    <p:notesMasterId r:id="rId6"/>
+    <p:notesMasterId r:id="rId7"/>
   </p:notesMasterIdLst>
   <p:sldIdLst>
     <p:sldId id="262" r:id="rId2"/>
-    <p:sldId id="263" r:id="rId3"/>
-    <p:sldId id="264" r:id="rId4"/>
-    <p:sldId id="265" r:id="rId5"/>
+    <p:sldId id="266" r:id="rId3"/>
+    <p:sldId id="263" r:id="rId4"/>
+    <p:sldId id="264" r:id="rId5"/>
+    <p:sldId id="265" r:id="rId6"/>
   </p:sldIdLst>
   <p:sldSz cx="12192000" cy="6858000"/>
   <p:notesSz cx="6858000" cy="9144000"/>
@@ -200,7 +201,7 @@
           <a:p>
             <a:fld id="{922FCDE8-9265-274C-B63C-E407950C8DE1}" type="datetimeFigureOut">
               <a:rPr lang="de-DE" smtClean="0"/>
-              <a:t>28.04.25</a:t>
+              <a:t>20.05.26</a:t>
             </a:fld>
             <a:endParaRPr lang="de-DE"/>
           </a:p>
@@ -582,7 +583,13 @@
   <p:cSld>
     <p:spTree>
       <p:nvGrpSpPr>
-        <p:cNvPr id="1" name="Shape 133"/>
+        <p:cNvPr id="1" name="Shape 133">
+          <a:extLst>
+            <a:ext uri="{FF2B5EF4-FFF2-40B4-BE49-F238E27FC236}">
+              <a16:creationId xmlns:a16="http://schemas.microsoft.com/office/drawing/2014/main" id="{46440F8D-E465-866C-FF1D-803423C01644}"/>
+            </a:ext>
+          </a:extLst>
+        </p:cNvPr>
         <p:cNvGrpSpPr/>
         <p:nvPr/>
       </p:nvGrpSpPr>
@@ -596,7 +603,13 @@
       </p:grpSpPr>
       <p:sp>
         <p:nvSpPr>
-          <p:cNvPr id="134" name="Google Shape;134;p8:notes"/>
+          <p:cNvPr id="134" name="Google Shape;134;p8:notes">
+            <a:extLst>
+              <a:ext uri="{FF2B5EF4-FFF2-40B4-BE49-F238E27FC236}">
+                <a16:creationId xmlns:a16="http://schemas.microsoft.com/office/drawing/2014/main" id="{14DF1287-5D11-C013-63A8-2644BFE82506}"/>
+              </a:ext>
+            </a:extLst>
+          </p:cNvPr>
           <p:cNvSpPr txBox="1">
             <a:spLocks noGrp="1"/>
           </p:cNvSpPr>
@@ -634,7 +647,13 @@
       </p:sp>
       <p:sp>
         <p:nvSpPr>
-          <p:cNvPr id="135" name="Google Shape;135;p8:notes"/>
+          <p:cNvPr id="135" name="Google Shape;135;p8:notes">
+            <a:extLst>
+              <a:ext uri="{FF2B5EF4-FFF2-40B4-BE49-F238E27FC236}">
+                <a16:creationId xmlns:a16="http://schemas.microsoft.com/office/drawing/2014/main" id="{66C5C8B7-BDD0-757B-7E7E-8DA21573A32F}"/>
+              </a:ext>
+            </a:extLst>
+          </p:cNvPr>
           <p:cNvSpPr>
             <a:spLocks noGrp="1" noRot="1" noChangeAspect="1"/>
           </p:cNvSpPr>
@@ -676,6 +695,115 @@
     </p:spTree>
     <p:extLst>
       <p:ext uri="{BB962C8B-B14F-4D97-AF65-F5344CB8AC3E}">
+        <p14:creationId xmlns:p14="http://schemas.microsoft.com/office/powerpoint/2010/main" val="3250691630"/>
+      </p:ext>
+    </p:extLst>
+  </p:cSld>
+  <p:clrMapOvr>
+    <a:masterClrMapping/>
+  </p:clrMapOvr>
+</p:notes>
+</file>
+
+<file path=ppt/notesSlides/notesSlide3.xml><?xml version="1.0" encoding="utf-8"?>
+<p:notes xmlns:a="http://schemas.openxmlformats.org/drawingml/2006/main" xmlns:r="http://schemas.openxmlformats.org/officeDocument/2006/relationships" xmlns:p="http://schemas.openxmlformats.org/presentationml/2006/main" showMasterSp="0" showMasterPhAnim="0">
+  <p:cSld>
+    <p:spTree>
+      <p:nvGrpSpPr>
+        <p:cNvPr id="1" name="Shape 133"/>
+        <p:cNvGrpSpPr/>
+        <p:nvPr/>
+      </p:nvGrpSpPr>
+      <p:grpSpPr>
+        <a:xfrm>
+          <a:off x="0" y="0"/>
+          <a:ext cx="0" cy="0"/>
+          <a:chOff x="0" y="0"/>
+          <a:chExt cx="0" cy="0"/>
+        </a:xfrm>
+      </p:grpSpPr>
+      <p:sp>
+        <p:nvSpPr>
+          <p:cNvPr id="134" name="Google Shape;134;p8:notes"/>
+          <p:cNvSpPr txBox="1">
+            <a:spLocks noGrp="1"/>
+          </p:cNvSpPr>
+          <p:nvPr>
+            <p:ph type="body" idx="1"/>
+          </p:nvPr>
+        </p:nvSpPr>
+        <p:spPr>
+          <a:xfrm>
+            <a:off x="914400" y="4343400"/>
+            <a:ext cx="5029200" cy="4114800"/>
+          </a:xfrm>
+          <a:prstGeom prst="rect">
+            <a:avLst/>
+          </a:prstGeom>
+        </p:spPr>
+        <p:txBody>
+          <a:bodyPr spcFirstLastPara="1" wrap="square" lIns="91425" tIns="45700" rIns="91425" bIns="45700" anchor="t" anchorCtr="0">
+            <a:noAutofit/>
+          </a:bodyPr>
+          <a:lstStyle/>
+          <a:p>
+            <a:pPr marL="0" lvl="0" indent="0" algn="l" rtl="0">
+              <a:spcBef>
+                <a:spcPts val="0"/>
+              </a:spcBef>
+              <a:spcAft>
+                <a:spcPts val="0"/>
+              </a:spcAft>
+              <a:buNone/>
+            </a:pPr>
+            <a:endParaRPr/>
+          </a:p>
+        </p:txBody>
+      </p:sp>
+      <p:sp>
+        <p:nvSpPr>
+          <p:cNvPr id="135" name="Google Shape;135;p8:notes"/>
+          <p:cNvSpPr>
+            <a:spLocks noGrp="1" noRot="1" noChangeAspect="1"/>
+          </p:cNvSpPr>
+          <p:nvPr>
+            <p:ph type="sldImg" idx="2"/>
+          </p:nvPr>
+        </p:nvSpPr>
+        <p:spPr>
+          <a:xfrm>
+            <a:off x="381000" y="685800"/>
+            <a:ext cx="6096000" cy="3429000"/>
+          </a:xfrm>
+          <a:custGeom>
+            <a:avLst/>
+            <a:gdLst/>
+            <a:ahLst/>
+            <a:cxnLst/>
+            <a:rect l="l" t="t" r="r" b="b"/>
+            <a:pathLst>
+              <a:path w="120000" h="120000" extrusionOk="0">
+                <a:moveTo>
+                  <a:pt x="0" y="0"/>
+                </a:moveTo>
+                <a:lnTo>
+                  <a:pt x="120000" y="0"/>
+                </a:lnTo>
+                <a:lnTo>
+                  <a:pt x="120000" y="120000"/>
+                </a:lnTo>
+                <a:lnTo>
+                  <a:pt x="0" y="120000"/>
+                </a:lnTo>
+                <a:close/>
+              </a:path>
+            </a:pathLst>
+          </a:custGeom>
+        </p:spPr>
+      </p:sp>
+    </p:spTree>
+    <p:extLst>
+      <p:ext uri="{BB962C8B-B14F-4D97-AF65-F5344CB8AC3E}">
         <p14:creationId xmlns:p14="http://schemas.microsoft.com/office/powerpoint/2010/main" val="1804148972"/>
       </p:ext>
     </p:extLst>
@@ -835,7 +963,7 @@
           <a:p>
             <a:fld id="{747B7DA0-53A4-8447-B8D4-5B08E7A75C15}" type="datetimeFigureOut">
               <a:rPr lang="de-DE" smtClean="0"/>
-              <a:t>28.04.25</a:t>
+              <a:t>20.05.26</a:t>
             </a:fld>
             <a:endParaRPr lang="de-DE"/>
           </a:p>
@@ -1035,7 +1163,7 @@
           <a:p>
             <a:fld id="{747B7DA0-53A4-8447-B8D4-5B08E7A75C15}" type="datetimeFigureOut">
               <a:rPr lang="de-DE" smtClean="0"/>
-              <a:t>28.04.25</a:t>
+              <a:t>20.05.26</a:t>
             </a:fld>
             <a:endParaRPr lang="de-DE"/>
           </a:p>
@@ -1245,7 +1373,7 @@
           <a:p>
             <a:fld id="{747B7DA0-53A4-8447-B8D4-5B08E7A75C15}" type="datetimeFigureOut">
               <a:rPr lang="de-DE" smtClean="0"/>
-              <a:t>28.04.25</a:t>
+              <a:t>20.05.26</a:t>
             </a:fld>
             <a:endParaRPr lang="de-DE"/>
           </a:p>
@@ -2055,7 +2183,7 @@
           <a:p>
             <a:fld id="{747B7DA0-53A4-8447-B8D4-5B08E7A75C15}" type="datetimeFigureOut">
               <a:rPr lang="de-DE" smtClean="0"/>
-              <a:t>28.04.25</a:t>
+              <a:t>20.05.26</a:t>
             </a:fld>
             <a:endParaRPr lang="de-DE"/>
           </a:p>
@@ -2331,7 +2459,7 @@
           <a:p>
             <a:fld id="{747B7DA0-53A4-8447-B8D4-5B08E7A75C15}" type="datetimeFigureOut">
               <a:rPr lang="de-DE" smtClean="0"/>
-              <a:t>28.04.25</a:t>
+              <a:t>20.05.26</a:t>
             </a:fld>
             <a:endParaRPr lang="de-DE"/>
           </a:p>
@@ -2599,7 +2727,7 @@
           <a:p>
             <a:fld id="{747B7DA0-53A4-8447-B8D4-5B08E7A75C15}" type="datetimeFigureOut">
               <a:rPr lang="de-DE" smtClean="0"/>
-              <a:t>28.04.25</a:t>
+              <a:t>20.05.26</a:t>
             </a:fld>
             <a:endParaRPr lang="de-DE"/>
           </a:p>
@@ -3014,7 +3142,7 @@
           <a:p>
             <a:fld id="{747B7DA0-53A4-8447-B8D4-5B08E7A75C15}" type="datetimeFigureOut">
               <a:rPr lang="de-DE" smtClean="0"/>
-              <a:t>28.04.25</a:t>
+              <a:t>20.05.26</a:t>
             </a:fld>
             <a:endParaRPr lang="de-DE"/>
           </a:p>
@@ -3156,7 +3284,7 @@
           <a:p>
             <a:fld id="{747B7DA0-53A4-8447-B8D4-5B08E7A75C15}" type="datetimeFigureOut">
               <a:rPr lang="de-DE" smtClean="0"/>
-              <a:t>28.04.25</a:t>
+              <a:t>20.05.26</a:t>
             </a:fld>
             <a:endParaRPr lang="de-DE"/>
           </a:p>
@@ -3269,7 +3397,7 @@
           <a:p>
             <a:fld id="{747B7DA0-53A4-8447-B8D4-5B08E7A75C15}" type="datetimeFigureOut">
               <a:rPr lang="de-DE" smtClean="0"/>
-              <a:t>28.04.25</a:t>
+              <a:t>20.05.26</a:t>
             </a:fld>
             <a:endParaRPr lang="de-DE"/>
           </a:p>
@@ -3582,7 +3710,7 @@
           <a:p>
             <a:fld id="{747B7DA0-53A4-8447-B8D4-5B08E7A75C15}" type="datetimeFigureOut">
               <a:rPr lang="de-DE" smtClean="0"/>
-              <a:t>28.04.25</a:t>
+              <a:t>20.05.26</a:t>
             </a:fld>
             <a:endParaRPr lang="de-DE"/>
           </a:p>
@@ -3871,7 +3999,7 @@
           <a:p>
             <a:fld id="{747B7DA0-53A4-8447-B8D4-5B08E7A75C15}" type="datetimeFigureOut">
               <a:rPr lang="de-DE" smtClean="0"/>
-              <a:t>28.04.25</a:t>
+              <a:t>20.05.26</a:t>
             </a:fld>
             <a:endParaRPr lang="de-DE"/>
           </a:p>
@@ -4114,7 +4242,7 @@
           <a:p>
             <a:fld id="{747B7DA0-53A4-8447-B8D4-5B08E7A75C15}" type="datetimeFigureOut">
               <a:rPr lang="de-DE" smtClean="0"/>
-              <a:t>28.04.25</a:t>
+              <a:t>20.05.26</a:t>
             </a:fld>
             <a:endParaRPr lang="de-DE"/>
           </a:p>
@@ -4957,7 +5085,7 @@
                 <a:latin typeface="Courier New" panose="02070309020205020404" pitchFamily="49" charset="0"/>
                 <a:cs typeface="Courier New" panose="02070309020205020404" pitchFamily="49" charset="0"/>
               </a:rPr>
-              <a:t>0</a:t>
+              <a:t>65536</a:t>
             </a:r>
           </a:p>
           <a:p>
@@ -4993,7 +5121,7 @@
                 <a:latin typeface="Courier New" panose="02070309020205020404" pitchFamily="49" charset="0"/>
                 <a:cs typeface="Courier New" panose="02070309020205020404" pitchFamily="49" charset="0"/>
               </a:rPr>
-              <a:t>4</a:t>
+              <a:t>65532</a:t>
             </a:r>
           </a:p>
           <a:p>
@@ -5120,16 +5248,12 @@
           </a:p>
           <a:p>
             <a:r>
-              <a:rPr lang="de-DE" b="1">
+              <a:rPr lang="de-DE" b="1" dirty="0">
                 <a:latin typeface="Courier New" panose="02070309020205020404" pitchFamily="49" charset="0"/>
                 <a:cs typeface="Courier New" panose="02070309020205020404" pitchFamily="49" charset="0"/>
               </a:rPr>
               <a:t>24-bit RGB</a:t>
             </a:r>
-            <a:endParaRPr lang="de-DE" b="1" dirty="0">
-              <a:latin typeface="Courier New" panose="02070309020205020404" pitchFamily="49" charset="0"/>
-              <a:cs typeface="Courier New" panose="02070309020205020404" pitchFamily="49" charset="0"/>
-            </a:endParaRPr>
           </a:p>
           <a:p>
             <a:r>
@@ -5256,6 +5380,791 @@
 </file>
 
 <file path=ppt/slides/slide2.xml><?xml version="1.0" encoding="utf-8"?>
+<p:sld xmlns:a="http://schemas.openxmlformats.org/drawingml/2006/main" xmlns:r="http://schemas.openxmlformats.org/officeDocument/2006/relationships" xmlns:p="http://schemas.openxmlformats.org/presentationml/2006/main">
+  <p:cSld>
+    <p:spTree>
+      <p:nvGrpSpPr>
+        <p:cNvPr id="1" name="Shape 136">
+          <a:extLst>
+            <a:ext uri="{FF2B5EF4-FFF2-40B4-BE49-F238E27FC236}">
+              <a16:creationId xmlns:a16="http://schemas.microsoft.com/office/drawing/2014/main" id="{7060284A-1A55-8BED-9DB8-F8DB32D3E8F8}"/>
+            </a:ext>
+          </a:extLst>
+        </p:cNvPr>
+        <p:cNvGrpSpPr/>
+        <p:nvPr/>
+      </p:nvGrpSpPr>
+      <p:grpSpPr>
+        <a:xfrm>
+          <a:off x="0" y="0"/>
+          <a:ext cx="0" cy="0"/>
+          <a:chOff x="0" y="0"/>
+          <a:chExt cx="0" cy="0"/>
+        </a:xfrm>
+      </p:grpSpPr>
+      <p:sp>
+        <p:nvSpPr>
+          <p:cNvPr id="2" name="TextBox 1">
+            <a:extLst>
+              <a:ext uri="{FF2B5EF4-FFF2-40B4-BE49-F238E27FC236}">
+                <a16:creationId xmlns:a16="http://schemas.microsoft.com/office/drawing/2014/main" id="{BDD94D13-0624-7449-431C-96EF9AD31851}"/>
+              </a:ext>
+            </a:extLst>
+          </p:cNvPr>
+          <p:cNvSpPr txBox="1"/>
+          <p:nvPr/>
+        </p:nvSpPr>
+        <p:spPr>
+          <a:xfrm>
+            <a:off x="2121853" y="365223"/>
+            <a:ext cx="9001758" cy="6463308"/>
+          </a:xfrm>
+          <a:prstGeom prst="rect">
+            <a:avLst/>
+          </a:prstGeom>
+          <a:noFill/>
+        </p:spPr>
+        <p:txBody>
+          <a:bodyPr wrap="square" rtlCol="0">
+            <a:spAutoFit/>
+          </a:bodyPr>
+          <a:lstStyle/>
+          <a:p>
+            <a:r>
+              <a:rPr lang="de-DE" b="1" dirty="0">
+                <a:latin typeface="Courier New" panose="02070309020205020404" pitchFamily="49" charset="0"/>
+                <a:cs typeface="Courier New" panose="02070309020205020404" pitchFamily="49" charset="0"/>
+              </a:rPr>
+              <a:t>8-bit </a:t>
+            </a:r>
+            <a:r>
+              <a:rPr lang="de-DE" b="1" dirty="0" err="1">
+                <a:latin typeface="Courier New" panose="02070309020205020404" pitchFamily="49" charset="0"/>
+                <a:cs typeface="Courier New" panose="02070309020205020404" pitchFamily="49" charset="0"/>
+              </a:rPr>
+              <a:t>unsigned</a:t>
+            </a:r>
+            <a:r>
+              <a:rPr lang="de-DE" b="1" dirty="0">
+                <a:latin typeface="Courier New" panose="02070309020205020404" pitchFamily="49" charset="0"/>
+                <a:cs typeface="Courier New" panose="02070309020205020404" pitchFamily="49" charset="0"/>
+              </a:rPr>
+              <a:t> integer</a:t>
+            </a:r>
+          </a:p>
+          <a:p>
+            <a:r>
+              <a:rPr lang="de-DE" dirty="0">
+                <a:latin typeface="Courier New" panose="02070309020205020404" pitchFamily="49" charset="0"/>
+                <a:cs typeface="Courier New" panose="02070309020205020404" pitchFamily="49" charset="0"/>
+              </a:rPr>
+              <a:t>00000000 = 0</a:t>
+            </a:r>
+          </a:p>
+          <a:p>
+            <a:r>
+              <a:rPr lang="de-DE" dirty="0">
+                <a:latin typeface="Courier New" panose="02070309020205020404" pitchFamily="49" charset="0"/>
+                <a:cs typeface="Courier New" panose="02070309020205020404" pitchFamily="49" charset="0"/>
+              </a:rPr>
+              <a:t>00000001 = 2</a:t>
+            </a:r>
+            <a:r>
+              <a:rPr lang="de-DE" baseline="30000" dirty="0">
+                <a:latin typeface="Courier New" panose="02070309020205020404" pitchFamily="49" charset="0"/>
+                <a:cs typeface="Courier New" panose="02070309020205020404" pitchFamily="49" charset="0"/>
+              </a:rPr>
+              <a:t>0</a:t>
+            </a:r>
+            <a:r>
+              <a:rPr lang="de-DE" dirty="0">
+                <a:latin typeface="Courier New" panose="02070309020205020404" pitchFamily="49" charset="0"/>
+                <a:cs typeface="Courier New" panose="02070309020205020404" pitchFamily="49" charset="0"/>
+              </a:rPr>
+              <a:t> = 1</a:t>
+            </a:r>
+          </a:p>
+          <a:p>
+            <a:r>
+              <a:rPr lang="de-DE" dirty="0">
+                <a:latin typeface="Courier New" panose="02070309020205020404" pitchFamily="49" charset="0"/>
+                <a:cs typeface="Courier New" panose="02070309020205020404" pitchFamily="49" charset="0"/>
+              </a:rPr>
+              <a:t>00000101 = 2</a:t>
+            </a:r>
+            <a:r>
+              <a:rPr lang="de-DE" baseline="30000" dirty="0">
+                <a:latin typeface="Courier New" panose="02070309020205020404" pitchFamily="49" charset="0"/>
+                <a:cs typeface="Courier New" panose="02070309020205020404" pitchFamily="49" charset="0"/>
+              </a:rPr>
+              <a:t>0 </a:t>
+            </a:r>
+            <a:r>
+              <a:rPr lang="de-DE" dirty="0">
+                <a:latin typeface="Courier New" panose="02070309020205020404" pitchFamily="49" charset="0"/>
+                <a:cs typeface="Courier New" panose="02070309020205020404" pitchFamily="49" charset="0"/>
+              </a:rPr>
+              <a:t>+ 2</a:t>
+            </a:r>
+            <a:r>
+              <a:rPr lang="de-DE" baseline="30000" dirty="0">
+                <a:latin typeface="Courier New" panose="02070309020205020404" pitchFamily="49" charset="0"/>
+                <a:cs typeface="Courier New" panose="02070309020205020404" pitchFamily="49" charset="0"/>
+              </a:rPr>
+              <a:t>2</a:t>
+            </a:r>
+            <a:r>
+              <a:rPr lang="de-DE" dirty="0">
+                <a:latin typeface="Courier New" panose="02070309020205020404" pitchFamily="49" charset="0"/>
+                <a:cs typeface="Courier New" panose="02070309020205020404" pitchFamily="49" charset="0"/>
+              </a:rPr>
+              <a:t> = 5</a:t>
+            </a:r>
+          </a:p>
+          <a:p>
+            <a:r>
+              <a:rPr lang="de-DE" dirty="0">
+                <a:latin typeface="Courier New" panose="02070309020205020404" pitchFamily="49" charset="0"/>
+                <a:cs typeface="Courier New" panose="02070309020205020404" pitchFamily="49" charset="0"/>
+              </a:rPr>
+              <a:t>11111111 = 2</a:t>
+            </a:r>
+            <a:r>
+              <a:rPr lang="de-DE" baseline="30000" dirty="0">
+                <a:latin typeface="Courier New" panose="02070309020205020404" pitchFamily="49" charset="0"/>
+                <a:cs typeface="Courier New" panose="02070309020205020404" pitchFamily="49" charset="0"/>
+              </a:rPr>
+              <a:t>0 </a:t>
+            </a:r>
+            <a:r>
+              <a:rPr lang="de-DE" dirty="0">
+                <a:latin typeface="Courier New" panose="02070309020205020404" pitchFamily="49" charset="0"/>
+                <a:cs typeface="Courier New" panose="02070309020205020404" pitchFamily="49" charset="0"/>
+              </a:rPr>
+              <a:t>+ 2</a:t>
+            </a:r>
+            <a:r>
+              <a:rPr lang="de-DE" baseline="30000" dirty="0">
+                <a:latin typeface="Courier New" panose="02070309020205020404" pitchFamily="49" charset="0"/>
+                <a:cs typeface="Courier New" panose="02070309020205020404" pitchFamily="49" charset="0"/>
+              </a:rPr>
+              <a:t>1</a:t>
+            </a:r>
+            <a:r>
+              <a:rPr lang="de-DE" dirty="0">
+                <a:latin typeface="Courier New" panose="02070309020205020404" pitchFamily="49" charset="0"/>
+                <a:cs typeface="Courier New" panose="02070309020205020404" pitchFamily="49" charset="0"/>
+              </a:rPr>
+              <a:t> + … + 2</a:t>
+            </a:r>
+            <a:r>
+              <a:rPr lang="de-DE" baseline="30000" dirty="0">
+                <a:latin typeface="Courier New" panose="02070309020205020404" pitchFamily="49" charset="0"/>
+                <a:cs typeface="Courier New" panose="02070309020205020404" pitchFamily="49" charset="0"/>
+              </a:rPr>
+              <a:t>7</a:t>
+            </a:r>
+            <a:r>
+              <a:rPr lang="de-DE" dirty="0">
+                <a:latin typeface="Courier New" panose="02070309020205020404" pitchFamily="49" charset="0"/>
+                <a:cs typeface="Courier New" panose="02070309020205020404" pitchFamily="49" charset="0"/>
+              </a:rPr>
+              <a:t> = 255 </a:t>
+            </a:r>
+          </a:p>
+          <a:p>
+            <a:endParaRPr lang="de-DE" dirty="0">
+              <a:latin typeface="Courier New" panose="02070309020205020404" pitchFamily="49" charset="0"/>
+              <a:cs typeface="Courier New" panose="02070309020205020404" pitchFamily="49" charset="0"/>
+            </a:endParaRPr>
+          </a:p>
+          <a:p>
+            <a:r>
+              <a:rPr lang="de-DE" b="1" dirty="0">
+                <a:latin typeface="Courier New" panose="02070309020205020404" pitchFamily="49" charset="0"/>
+                <a:cs typeface="Courier New" panose="02070309020205020404" pitchFamily="49" charset="0"/>
+              </a:rPr>
+              <a:t>16-bit </a:t>
+            </a:r>
+            <a:r>
+              <a:rPr lang="de-DE" b="1" dirty="0" err="1">
+                <a:latin typeface="Courier New" panose="02070309020205020404" pitchFamily="49" charset="0"/>
+                <a:cs typeface="Courier New" panose="02070309020205020404" pitchFamily="49" charset="0"/>
+              </a:rPr>
+              <a:t>unsigned</a:t>
+            </a:r>
+            <a:r>
+              <a:rPr lang="de-DE" b="1" dirty="0">
+                <a:latin typeface="Courier New" panose="02070309020205020404" pitchFamily="49" charset="0"/>
+                <a:cs typeface="Courier New" panose="02070309020205020404" pitchFamily="49" charset="0"/>
+              </a:rPr>
+              <a:t> integer</a:t>
+            </a:r>
+          </a:p>
+          <a:p>
+            <a:r>
+              <a:rPr lang="de-DE" dirty="0">
+                <a:latin typeface="Courier New" panose="02070309020205020404" pitchFamily="49" charset="0"/>
+                <a:cs typeface="Courier New" panose="02070309020205020404" pitchFamily="49" charset="0"/>
+              </a:rPr>
+              <a:t>1111111111111111 = 2</a:t>
+            </a:r>
+            <a:r>
+              <a:rPr lang="de-DE" baseline="30000" dirty="0">
+                <a:latin typeface="Courier New" panose="02070309020205020404" pitchFamily="49" charset="0"/>
+                <a:cs typeface="Courier New" panose="02070309020205020404" pitchFamily="49" charset="0"/>
+              </a:rPr>
+              <a:t>0 </a:t>
+            </a:r>
+            <a:r>
+              <a:rPr lang="de-DE" dirty="0">
+                <a:latin typeface="Courier New" panose="02070309020205020404" pitchFamily="49" charset="0"/>
+                <a:cs typeface="Courier New" panose="02070309020205020404" pitchFamily="49" charset="0"/>
+              </a:rPr>
+              <a:t>+ 2</a:t>
+            </a:r>
+            <a:r>
+              <a:rPr lang="de-DE" baseline="30000" dirty="0">
+                <a:latin typeface="Courier New" panose="02070309020205020404" pitchFamily="49" charset="0"/>
+                <a:cs typeface="Courier New" panose="02070309020205020404" pitchFamily="49" charset="0"/>
+              </a:rPr>
+              <a:t>1</a:t>
+            </a:r>
+            <a:r>
+              <a:rPr lang="de-DE" dirty="0">
+                <a:latin typeface="Courier New" panose="02070309020205020404" pitchFamily="49" charset="0"/>
+                <a:cs typeface="Courier New" panose="02070309020205020404" pitchFamily="49" charset="0"/>
+              </a:rPr>
+              <a:t> + … + 2</a:t>
+            </a:r>
+            <a:r>
+              <a:rPr lang="de-DE" baseline="30000" dirty="0">
+                <a:latin typeface="Courier New" panose="02070309020205020404" pitchFamily="49" charset="0"/>
+                <a:cs typeface="Courier New" panose="02070309020205020404" pitchFamily="49" charset="0"/>
+              </a:rPr>
+              <a:t>15</a:t>
+            </a:r>
+            <a:r>
+              <a:rPr lang="de-DE" dirty="0">
+                <a:latin typeface="Courier New" panose="02070309020205020404" pitchFamily="49" charset="0"/>
+                <a:cs typeface="Courier New" panose="02070309020205020404" pitchFamily="49" charset="0"/>
+              </a:rPr>
+              <a:t> = 65535</a:t>
+            </a:r>
+          </a:p>
+          <a:p>
+            <a:r>
+              <a:rPr lang="de-DE" dirty="0">
+                <a:latin typeface="Courier New" panose="02070309020205020404" pitchFamily="49" charset="0"/>
+                <a:cs typeface="Courier New" panose="02070309020205020404" pitchFamily="49" charset="0"/>
+              </a:rPr>
+              <a:t>1000000000000000 = 2</a:t>
+            </a:r>
+            <a:r>
+              <a:rPr lang="de-DE" baseline="30000" dirty="0">
+                <a:latin typeface="Courier New" panose="02070309020205020404" pitchFamily="49" charset="0"/>
+                <a:cs typeface="Courier New" panose="02070309020205020404" pitchFamily="49" charset="0"/>
+              </a:rPr>
+              <a:t>15</a:t>
+            </a:r>
+            <a:r>
+              <a:rPr lang="de-DE" dirty="0">
+                <a:latin typeface="Courier New" panose="02070309020205020404" pitchFamily="49" charset="0"/>
+                <a:cs typeface="Courier New" panose="02070309020205020404" pitchFamily="49" charset="0"/>
+              </a:rPr>
+              <a:t> = 32768</a:t>
+            </a:r>
+          </a:p>
+          <a:p>
+            <a:r>
+              <a:rPr lang="de-DE" dirty="0">
+                <a:latin typeface="Courier New" panose="02070309020205020404" pitchFamily="49" charset="0"/>
+                <a:cs typeface="Courier New" panose="02070309020205020404" pitchFamily="49" charset="0"/>
+              </a:rPr>
+              <a:t>0000111111111111 = 2</a:t>
+            </a:r>
+            <a:r>
+              <a:rPr lang="de-DE" baseline="30000" dirty="0">
+                <a:latin typeface="Courier New" panose="02070309020205020404" pitchFamily="49" charset="0"/>
+                <a:cs typeface="Courier New" panose="02070309020205020404" pitchFamily="49" charset="0"/>
+              </a:rPr>
+              <a:t>0 </a:t>
+            </a:r>
+            <a:r>
+              <a:rPr lang="de-DE" dirty="0">
+                <a:latin typeface="Courier New" panose="02070309020205020404" pitchFamily="49" charset="0"/>
+                <a:cs typeface="Courier New" panose="02070309020205020404" pitchFamily="49" charset="0"/>
+              </a:rPr>
+              <a:t>+ 2</a:t>
+            </a:r>
+            <a:r>
+              <a:rPr lang="de-DE" baseline="30000" dirty="0">
+                <a:latin typeface="Courier New" panose="02070309020205020404" pitchFamily="49" charset="0"/>
+                <a:cs typeface="Courier New" panose="02070309020205020404" pitchFamily="49" charset="0"/>
+              </a:rPr>
+              <a:t>1</a:t>
+            </a:r>
+            <a:r>
+              <a:rPr lang="de-DE" dirty="0">
+                <a:latin typeface="Courier New" panose="02070309020205020404" pitchFamily="49" charset="0"/>
+                <a:cs typeface="Courier New" panose="02070309020205020404" pitchFamily="49" charset="0"/>
+              </a:rPr>
+              <a:t> + … + 2</a:t>
+            </a:r>
+            <a:r>
+              <a:rPr lang="de-DE" baseline="30000" dirty="0">
+                <a:latin typeface="Courier New" panose="02070309020205020404" pitchFamily="49" charset="0"/>
+                <a:cs typeface="Courier New" panose="02070309020205020404" pitchFamily="49" charset="0"/>
+              </a:rPr>
+              <a:t>11 </a:t>
+            </a:r>
+            <a:r>
+              <a:rPr lang="de-DE" dirty="0">
+                <a:latin typeface="Courier New" panose="02070309020205020404" pitchFamily="49" charset="0"/>
+                <a:cs typeface="Courier New" panose="02070309020205020404" pitchFamily="49" charset="0"/>
+              </a:rPr>
+              <a:t>= 4095</a:t>
+            </a:r>
+          </a:p>
+          <a:p>
+            <a:r>
+              <a:rPr lang="de-DE" dirty="0">
+                <a:latin typeface="Courier New" panose="02070309020205020404" pitchFamily="49" charset="0"/>
+                <a:cs typeface="Courier New" panose="02070309020205020404" pitchFamily="49" charset="0"/>
+              </a:rPr>
+              <a:t> </a:t>
+            </a:r>
+          </a:p>
+          <a:p>
+            <a:r>
+              <a:rPr lang="de-DE" b="1" dirty="0">
+                <a:latin typeface="Courier New" panose="02070309020205020404" pitchFamily="49" charset="0"/>
+                <a:cs typeface="Courier New" panose="02070309020205020404" pitchFamily="49" charset="0"/>
+              </a:rPr>
+              <a:t>16-bit </a:t>
+            </a:r>
+            <a:r>
+              <a:rPr lang="de-DE" b="1" dirty="0" err="1">
+                <a:latin typeface="Courier New" panose="02070309020205020404" pitchFamily="49" charset="0"/>
+                <a:cs typeface="Courier New" panose="02070309020205020404" pitchFamily="49" charset="0"/>
+              </a:rPr>
+              <a:t>signed</a:t>
+            </a:r>
+            <a:r>
+              <a:rPr lang="de-DE" b="1" dirty="0">
+                <a:latin typeface="Courier New" panose="02070309020205020404" pitchFamily="49" charset="0"/>
+                <a:cs typeface="Courier New" panose="02070309020205020404" pitchFamily="49" charset="0"/>
+              </a:rPr>
+              <a:t> integer</a:t>
+            </a:r>
+          </a:p>
+          <a:p>
+            <a:r>
+              <a:rPr lang="de-DE" dirty="0">
+                <a:solidFill>
+                  <a:schemeClr val="accent2"/>
+                </a:solidFill>
+                <a:latin typeface="Courier New" panose="02070309020205020404" pitchFamily="49" charset="0"/>
+                <a:cs typeface="Courier New" panose="02070309020205020404" pitchFamily="49" charset="0"/>
+              </a:rPr>
+              <a:t>0</a:t>
+            </a:r>
+            <a:r>
+              <a:rPr lang="de-DE" dirty="0">
+                <a:latin typeface="Courier New" panose="02070309020205020404" pitchFamily="49" charset="0"/>
+                <a:cs typeface="Courier New" panose="02070309020205020404" pitchFamily="49" charset="0"/>
+              </a:rPr>
+              <a:t>000000000000000 = </a:t>
+            </a:r>
+            <a:r>
+              <a:rPr lang="de-DE" dirty="0">
+                <a:solidFill>
+                  <a:schemeClr val="accent2"/>
+                </a:solidFill>
+                <a:latin typeface="Courier New" panose="02070309020205020404" pitchFamily="49" charset="0"/>
+                <a:cs typeface="Courier New" panose="02070309020205020404" pitchFamily="49" charset="0"/>
+              </a:rPr>
+              <a:t>+</a:t>
+            </a:r>
+            <a:r>
+              <a:rPr lang="de-DE" dirty="0">
+                <a:latin typeface="Courier New" panose="02070309020205020404" pitchFamily="49" charset="0"/>
+                <a:cs typeface="Courier New" panose="02070309020205020404" pitchFamily="49" charset="0"/>
+              </a:rPr>
+              <a:t>0</a:t>
+            </a:r>
+          </a:p>
+          <a:p>
+            <a:r>
+              <a:rPr lang="de-DE" dirty="0">
+                <a:solidFill>
+                  <a:schemeClr val="accent2"/>
+                </a:solidFill>
+                <a:latin typeface="Courier New" panose="02070309020205020404" pitchFamily="49" charset="0"/>
+                <a:cs typeface="Courier New" panose="02070309020205020404" pitchFamily="49" charset="0"/>
+              </a:rPr>
+              <a:t>1</a:t>
+            </a:r>
+            <a:r>
+              <a:rPr lang="de-DE" dirty="0">
+                <a:latin typeface="Courier New" panose="02070309020205020404" pitchFamily="49" charset="0"/>
+                <a:cs typeface="Courier New" panose="02070309020205020404" pitchFamily="49" charset="0"/>
+              </a:rPr>
+              <a:t>000000000000000 = </a:t>
+            </a:r>
+            <a:r>
+              <a:rPr lang="de-DE" dirty="0">
+                <a:solidFill>
+                  <a:schemeClr val="accent2"/>
+                </a:solidFill>
+                <a:latin typeface="Courier New" panose="02070309020205020404" pitchFamily="49" charset="0"/>
+                <a:cs typeface="Courier New" panose="02070309020205020404" pitchFamily="49" charset="0"/>
+              </a:rPr>
+              <a:t>-</a:t>
+            </a:r>
+            <a:r>
+              <a:rPr lang="de-DE" dirty="0">
+                <a:latin typeface="Courier New" panose="02070309020205020404" pitchFamily="49" charset="0"/>
+                <a:cs typeface="Courier New" panose="02070309020205020404" pitchFamily="49" charset="0"/>
+              </a:rPr>
+              <a:t>0</a:t>
+            </a:r>
+          </a:p>
+          <a:p>
+            <a:r>
+              <a:rPr lang="de-DE" dirty="0">
+                <a:solidFill>
+                  <a:schemeClr val="accent2"/>
+                </a:solidFill>
+                <a:latin typeface="Courier New" panose="02070309020205020404" pitchFamily="49" charset="0"/>
+                <a:cs typeface="Courier New" panose="02070309020205020404" pitchFamily="49" charset="0"/>
+              </a:rPr>
+              <a:t>1</a:t>
+            </a:r>
+            <a:r>
+              <a:rPr lang="de-DE" dirty="0">
+                <a:latin typeface="Courier New" panose="02070309020205020404" pitchFamily="49" charset="0"/>
+                <a:cs typeface="Courier New" panose="02070309020205020404" pitchFamily="49" charset="0"/>
+              </a:rPr>
+              <a:t>000000000000100 = </a:t>
+            </a:r>
+            <a:r>
+              <a:rPr lang="de-DE" dirty="0">
+                <a:solidFill>
+                  <a:schemeClr val="accent2"/>
+                </a:solidFill>
+                <a:latin typeface="Courier New" panose="02070309020205020404" pitchFamily="49" charset="0"/>
+                <a:cs typeface="Courier New" panose="02070309020205020404" pitchFamily="49" charset="0"/>
+              </a:rPr>
+              <a:t>-</a:t>
+            </a:r>
+            <a:r>
+              <a:rPr lang="de-DE" dirty="0">
+                <a:latin typeface="Courier New" panose="02070309020205020404" pitchFamily="49" charset="0"/>
+                <a:cs typeface="Courier New" panose="02070309020205020404" pitchFamily="49" charset="0"/>
+              </a:rPr>
+              <a:t>4</a:t>
+            </a:r>
+          </a:p>
+          <a:p>
+            <a:endParaRPr lang="de-DE" dirty="0">
+              <a:latin typeface="Courier New" panose="02070309020205020404" pitchFamily="49" charset="0"/>
+              <a:cs typeface="Courier New" panose="02070309020205020404" pitchFamily="49" charset="0"/>
+            </a:endParaRPr>
+          </a:p>
+          <a:p>
+            <a:r>
+              <a:rPr lang="de-DE" b="1" dirty="0">
+                <a:latin typeface="Courier New" panose="02070309020205020404" pitchFamily="49" charset="0"/>
+                <a:cs typeface="Courier New" panose="02070309020205020404" pitchFamily="49" charset="0"/>
+              </a:rPr>
+              <a:t>32-bit </a:t>
+            </a:r>
+            <a:r>
+              <a:rPr lang="de-DE" b="1" dirty="0" err="1">
+                <a:latin typeface="Courier New" panose="02070309020205020404" pitchFamily="49" charset="0"/>
+                <a:cs typeface="Courier New" panose="02070309020205020404" pitchFamily="49" charset="0"/>
+              </a:rPr>
+              <a:t>floating</a:t>
+            </a:r>
+            <a:r>
+              <a:rPr lang="de-DE" b="1" dirty="0">
+                <a:latin typeface="Courier New" panose="02070309020205020404" pitchFamily="49" charset="0"/>
+                <a:cs typeface="Courier New" panose="02070309020205020404" pitchFamily="49" charset="0"/>
+              </a:rPr>
+              <a:t> </a:t>
+            </a:r>
+            <a:r>
+              <a:rPr lang="de-DE" b="1" dirty="0" err="1">
+                <a:latin typeface="Courier New" panose="02070309020205020404" pitchFamily="49" charset="0"/>
+                <a:cs typeface="Courier New" panose="02070309020205020404" pitchFamily="49" charset="0"/>
+              </a:rPr>
+              <a:t>point</a:t>
+            </a:r>
+            <a:endParaRPr lang="de-DE" b="1" dirty="0">
+              <a:latin typeface="Courier New" panose="02070309020205020404" pitchFamily="49" charset="0"/>
+              <a:cs typeface="Courier New" panose="02070309020205020404" pitchFamily="49" charset="0"/>
+            </a:endParaRPr>
+          </a:p>
+          <a:p>
+            <a:r>
+              <a:rPr lang="de-DE" dirty="0">
+                <a:solidFill>
+                  <a:schemeClr val="accent2"/>
+                </a:solidFill>
+                <a:latin typeface="Courier New" panose="02070309020205020404" pitchFamily="49" charset="0"/>
+                <a:cs typeface="Courier New" panose="02070309020205020404" pitchFamily="49" charset="0"/>
+              </a:rPr>
+              <a:t>1</a:t>
+            </a:r>
+            <a:r>
+              <a:rPr lang="de-DE" dirty="0">
+                <a:solidFill>
+                  <a:schemeClr val="accent1"/>
+                </a:solidFill>
+                <a:latin typeface="Courier New" panose="02070309020205020404" pitchFamily="49" charset="0"/>
+                <a:cs typeface="Courier New" panose="02070309020205020404" pitchFamily="49" charset="0"/>
+              </a:rPr>
+              <a:t>00000010</a:t>
+            </a:r>
+            <a:r>
+              <a:rPr lang="de-DE" dirty="0">
+                <a:latin typeface="Courier New" panose="02070309020205020404" pitchFamily="49" charset="0"/>
+                <a:cs typeface="Courier New" panose="02070309020205020404" pitchFamily="49" charset="0"/>
+              </a:rPr>
+              <a:t>00000000000000000000010 = </a:t>
+            </a:r>
+            <a:r>
+              <a:rPr lang="de-DE" dirty="0">
+                <a:solidFill>
+                  <a:schemeClr val="accent2"/>
+                </a:solidFill>
+                <a:latin typeface="Courier New" panose="02070309020205020404" pitchFamily="49" charset="0"/>
+                <a:cs typeface="Courier New" panose="02070309020205020404" pitchFamily="49" charset="0"/>
+              </a:rPr>
+              <a:t>- </a:t>
+            </a:r>
+            <a:r>
+              <a:rPr lang="de-DE" dirty="0">
+                <a:latin typeface="Courier New" panose="02070309020205020404" pitchFamily="49" charset="0"/>
+                <a:cs typeface="Courier New" panose="02070309020205020404" pitchFamily="49" charset="0"/>
+              </a:rPr>
+              <a:t>1.?</a:t>
+            </a:r>
+            <a:r>
+              <a:rPr lang="de-DE" dirty="0">
+                <a:solidFill>
+                  <a:schemeClr val="accent2"/>
+                </a:solidFill>
+                <a:latin typeface="Courier New" panose="02070309020205020404" pitchFamily="49" charset="0"/>
+                <a:cs typeface="Courier New" panose="02070309020205020404" pitchFamily="49" charset="0"/>
+              </a:rPr>
+              <a:t> </a:t>
+            </a:r>
+            <a:r>
+              <a:rPr lang="de-DE" dirty="0">
+                <a:solidFill>
+                  <a:schemeClr val="accent1"/>
+                </a:solidFill>
+                <a:latin typeface="Courier New" panose="02070309020205020404" pitchFamily="49" charset="0"/>
+                <a:cs typeface="Courier New" panose="02070309020205020404" pitchFamily="49" charset="0"/>
+              </a:rPr>
+              <a:t>2</a:t>
+            </a:r>
+            <a:r>
+              <a:rPr lang="de-DE" baseline="30000" dirty="0">
+                <a:solidFill>
+                  <a:schemeClr val="accent1"/>
+                </a:solidFill>
+                <a:latin typeface="Courier New" panose="02070309020205020404" pitchFamily="49" charset="0"/>
+                <a:cs typeface="Courier New" panose="02070309020205020404" pitchFamily="49" charset="0"/>
+              </a:rPr>
+              <a:t>?</a:t>
+            </a:r>
+          </a:p>
+          <a:p>
+            <a:endParaRPr lang="de-DE" dirty="0">
+              <a:latin typeface="Courier New" panose="02070309020205020404" pitchFamily="49" charset="0"/>
+              <a:cs typeface="Courier New" panose="02070309020205020404" pitchFamily="49" charset="0"/>
+            </a:endParaRPr>
+          </a:p>
+          <a:p>
+            <a:r>
+              <a:rPr lang="de-DE" b="1">
+                <a:latin typeface="Courier New" panose="02070309020205020404" pitchFamily="49" charset="0"/>
+                <a:cs typeface="Courier New" panose="02070309020205020404" pitchFamily="49" charset="0"/>
+              </a:rPr>
+              <a:t>24-bit RGB</a:t>
+            </a:r>
+            <a:endParaRPr lang="de-DE" b="1" dirty="0">
+              <a:latin typeface="Courier New" panose="02070309020205020404" pitchFamily="49" charset="0"/>
+              <a:cs typeface="Courier New" panose="02070309020205020404" pitchFamily="49" charset="0"/>
+            </a:endParaRPr>
+          </a:p>
+          <a:p>
+            <a:r>
+              <a:rPr lang="de-DE" dirty="0">
+                <a:solidFill>
+                  <a:srgbClr val="FF0000"/>
+                </a:solidFill>
+                <a:latin typeface="Courier New" panose="02070309020205020404" pitchFamily="49" charset="0"/>
+                <a:cs typeface="Courier New" panose="02070309020205020404" pitchFamily="49" charset="0"/>
+              </a:rPr>
+              <a:t>11111111</a:t>
+            </a:r>
+            <a:r>
+              <a:rPr lang="de-DE" dirty="0">
+                <a:solidFill>
+                  <a:srgbClr val="00B050"/>
+                </a:solidFill>
+                <a:latin typeface="Courier New" panose="02070309020205020404" pitchFamily="49" charset="0"/>
+                <a:cs typeface="Courier New" panose="02070309020205020404" pitchFamily="49" charset="0"/>
+              </a:rPr>
+              <a:t>00000000</a:t>
+            </a:r>
+            <a:r>
+              <a:rPr lang="de-DE" dirty="0">
+                <a:solidFill>
+                  <a:srgbClr val="0070C0"/>
+                </a:solidFill>
+                <a:latin typeface="Courier New" panose="02070309020205020404" pitchFamily="49" charset="0"/>
+                <a:cs typeface="Courier New" panose="02070309020205020404" pitchFamily="49" charset="0"/>
+              </a:rPr>
+              <a:t>01000000 </a:t>
+            </a:r>
+            <a:r>
+              <a:rPr lang="de-DE" dirty="0">
+                <a:latin typeface="Courier New" panose="02070309020205020404" pitchFamily="49" charset="0"/>
+                <a:cs typeface="Courier New" panose="02070309020205020404" pitchFamily="49" charset="0"/>
+              </a:rPr>
+              <a:t>= (</a:t>
+            </a:r>
+            <a:r>
+              <a:rPr lang="de-DE" dirty="0">
+                <a:solidFill>
+                  <a:srgbClr val="FF0000"/>
+                </a:solidFill>
+                <a:latin typeface="Courier New" panose="02070309020205020404" pitchFamily="49" charset="0"/>
+                <a:cs typeface="Courier New" panose="02070309020205020404" pitchFamily="49" charset="0"/>
+              </a:rPr>
+              <a:t>255</a:t>
+            </a:r>
+            <a:r>
+              <a:rPr lang="de-DE" dirty="0">
+                <a:latin typeface="Courier New" panose="02070309020205020404" pitchFamily="49" charset="0"/>
+                <a:cs typeface="Courier New" panose="02070309020205020404" pitchFamily="49" charset="0"/>
+              </a:rPr>
+              <a:t>,</a:t>
+            </a:r>
+            <a:r>
+              <a:rPr lang="de-DE" dirty="0">
+                <a:solidFill>
+                  <a:srgbClr val="00B050"/>
+                </a:solidFill>
+                <a:latin typeface="Courier New" panose="02070309020205020404" pitchFamily="49" charset="0"/>
+                <a:cs typeface="Courier New" panose="02070309020205020404" pitchFamily="49" charset="0"/>
+              </a:rPr>
+              <a:t>0</a:t>
+            </a:r>
+            <a:r>
+              <a:rPr lang="de-DE" dirty="0">
+                <a:latin typeface="Courier New" panose="02070309020205020404" pitchFamily="49" charset="0"/>
+                <a:cs typeface="Courier New" panose="02070309020205020404" pitchFamily="49" charset="0"/>
+              </a:rPr>
+              <a:t>,</a:t>
+            </a:r>
+            <a:r>
+              <a:rPr lang="de-DE" dirty="0">
+                <a:solidFill>
+                  <a:srgbClr val="0070C0"/>
+                </a:solidFill>
+                <a:latin typeface="Courier New" panose="02070309020205020404" pitchFamily="49" charset="0"/>
+                <a:cs typeface="Courier New" panose="02070309020205020404" pitchFamily="49" charset="0"/>
+              </a:rPr>
+              <a:t>64</a:t>
+            </a:r>
+            <a:r>
+              <a:rPr lang="de-DE" dirty="0">
+                <a:latin typeface="Courier New" panose="02070309020205020404" pitchFamily="49" charset="0"/>
+                <a:cs typeface="Courier New" panose="02070309020205020404" pitchFamily="49" charset="0"/>
+              </a:rPr>
+              <a:t>)</a:t>
+            </a:r>
+            <a:endParaRPr lang="de-DE" dirty="0">
+              <a:solidFill>
+                <a:srgbClr val="0070C0"/>
+              </a:solidFill>
+              <a:latin typeface="Courier New" panose="02070309020205020404" pitchFamily="49" charset="0"/>
+              <a:cs typeface="Courier New" panose="02070309020205020404" pitchFamily="49" charset="0"/>
+            </a:endParaRPr>
+          </a:p>
+          <a:p>
+            <a:endParaRPr lang="de-DE" dirty="0">
+              <a:latin typeface="Courier New" panose="02070309020205020404" pitchFamily="49" charset="0"/>
+              <a:cs typeface="Courier New" panose="02070309020205020404" pitchFamily="49" charset="0"/>
+            </a:endParaRPr>
+          </a:p>
+          <a:p>
+            <a:endParaRPr lang="de-DE" dirty="0">
+              <a:latin typeface="Courier New" panose="02070309020205020404" pitchFamily="49" charset="0"/>
+              <a:cs typeface="Courier New" panose="02070309020205020404" pitchFamily="49" charset="0"/>
+            </a:endParaRPr>
+          </a:p>
+        </p:txBody>
+      </p:sp>
+      <p:sp>
+        <p:nvSpPr>
+          <p:cNvPr id="3" name="TextBox 2">
+            <a:extLst>
+              <a:ext uri="{FF2B5EF4-FFF2-40B4-BE49-F238E27FC236}">
+                <a16:creationId xmlns:a16="http://schemas.microsoft.com/office/drawing/2014/main" id="{5361021A-0249-AD2A-2551-58D152A347FC}"/>
+              </a:ext>
+            </a:extLst>
+          </p:cNvPr>
+          <p:cNvSpPr txBox="1"/>
+          <p:nvPr/>
+        </p:nvSpPr>
+        <p:spPr>
+          <a:xfrm>
+            <a:off x="5394960" y="3911600"/>
+            <a:ext cx="1725601" cy="369332"/>
+          </a:xfrm>
+          <a:prstGeom prst="rect">
+            <a:avLst/>
+          </a:prstGeom>
+          <a:noFill/>
+        </p:spPr>
+        <p:txBody>
+          <a:bodyPr wrap="none" rtlCol="0">
+            <a:spAutoFit/>
+          </a:bodyPr>
+          <a:lstStyle/>
+          <a:p>
+            <a:r>
+              <a:rPr lang="en-GB" dirty="0"/>
+              <a:t>W</a:t>
+            </a:r>
+            <a:r>
+              <a:rPr lang="en-DE" dirty="0"/>
+              <a:t>rong decoding</a:t>
+            </a:r>
+          </a:p>
+        </p:txBody>
+      </p:sp>
+    </p:spTree>
+    <p:extLst>
+      <p:ext uri="{BB962C8B-B14F-4D97-AF65-F5344CB8AC3E}">
+        <p14:creationId xmlns:p14="http://schemas.microsoft.com/office/powerpoint/2010/main" val="1537548408"/>
+      </p:ext>
+    </p:extLst>
+  </p:cSld>
+  <p:clrMapOvr>
+    <a:masterClrMapping/>
+  </p:clrMapOvr>
+</p:sld>
+</file>
+
+<file path=ppt/slides/slide3.xml><?xml version="1.0" encoding="utf-8"?>
 <p:sld xmlns:a="http://schemas.openxmlformats.org/drawingml/2006/main" xmlns:r="http://schemas.openxmlformats.org/officeDocument/2006/relationships" xmlns:p="http://schemas.openxmlformats.org/presentationml/2006/main">
   <p:cSld>
     <p:spTree>
@@ -5353,7 +6262,7 @@
 </p:sld>
 </file>
 
-<file path=ppt/slides/slide3.xml><?xml version="1.0" encoding="utf-8"?>
+<file path=ppt/slides/slide4.xml><?xml version="1.0" encoding="utf-8"?>
 <p:sld xmlns:a="http://schemas.openxmlformats.org/drawingml/2006/main" xmlns:r="http://schemas.openxmlformats.org/officeDocument/2006/relationships" xmlns:p="http://schemas.openxmlformats.org/presentationml/2006/main">
   <p:cSld>
     <p:spTree>
@@ -5464,7 +6373,7 @@
 </p:sld>
 </file>
 
-<file path=ppt/slides/slide4.xml><?xml version="1.0" encoding="utf-8"?>
+<file path=ppt/slides/slide5.xml><?xml version="1.0" encoding="utf-8"?>
 <p:sld xmlns:a="http://schemas.openxmlformats.org/drawingml/2006/main" xmlns:r="http://schemas.openxmlformats.org/officeDocument/2006/relationships" xmlns:p="http://schemas.openxmlformats.org/presentationml/2006/main">
   <p:cSld>
     <p:spTree>

</xml_diff>